<commit_message>
Revise Q4 OKR plan: remove livestream, make content concrete
- Removed all 专题直播/livestream references (KR, roadmap, resources)
- Replaced vague corporate phrasing with specific actionable items
- Added concrete deliverables:埋点, 法规速递邮件, 深度专题文章
- Tightened objective, background, KRs, roadmap, and checklist

Co-Authored-By: Claude Opus 4.6 <noreply@anthropic.com>
Claude-Session: https://claude.ai/code/session_015nf3knxVoVVLYAWgtjzRg9
</commit_message>
<xml_diff>
--- a/汽车板块Q4推广计划.pptx
+++ b/汽车板块Q4推广计划.pptx
@@ -2794,7 +2794,7 @@
                 <a:ea typeface="Arial" pitchFamily="34" charset="-122"/>
                 <a:cs typeface="Arial" pitchFamily="34" charset="-120"/>
               </a:rPr>
-              <a:t>E-mark / 一点通合规评估工具已上线并持续迭代，具备逐条订阅、认证旅程、成熟度打分等留存设计</a:t>
+              <a:t>一点通合规评估工具已上线：逐条订阅提醒、认证旅程 9 站导航、成熟度矩阵打分、缺口分级表均可用</a:t>
             </a:r>
             <a:endParaRPr lang="en-US" sz="1150" dirty="0"/>
           </a:p>
@@ -2903,7 +2903,7 @@
                 <a:ea typeface="Arial" pitchFamily="34" charset="-122"/>
                 <a:cs typeface="Arial" pitchFamily="34" charset="-120"/>
               </a:rPr>
-              <a:t>《全球及中国汽车法规标准月报》稳定按月产出，形成固定内容触点</a:t>
+              <a:t>《全球及中国汽车法规标准月报》按月产出，覆盖 60+ 目标国、10 维度法规动态</a:t>
             </a:r>
             <a:endParaRPr lang="en-US" sz="1150" dirty="0"/>
           </a:p>
@@ -3012,7 +3012,7 @@
                 <a:ea typeface="Arial" pitchFamily="34" charset="-122"/>
                 <a:cs typeface="Arial" pitchFamily="34" charset="-120"/>
               </a:rPr>
-              <a:t>「汽车制造」系列推广文章周更机制已建立，覆盖一定读者基础</a:t>
+              <a:t>「汽车制造」系列推广文章周更发布，已积累固定读者群</a:t>
             </a:r>
             <a:endParaRPr lang="en-US" sz="1150" dirty="0"/>
           </a:p>
@@ -3121,7 +3121,7 @@
                 <a:ea typeface="Arial" pitchFamily="34" charset="-122"/>
                 <a:cs typeface="Arial" pitchFamily="34" charset="-120"/>
               </a:rPr>
-              <a:t>与汽研等核心客户已有稳定的法规数据交付合作</a:t>
+              <a:t>汽研等核心客户有在执行的法规数据交付合作，可作为深化基础</a:t>
             </a:r>
             <a:endParaRPr lang="en-US" sz="1150" dirty="0"/>
           </a:p>
@@ -3319,7 +3319,7 @@
                 <a:ea typeface="Arial" pitchFamily="34" charset="-122"/>
                 <a:cs typeface="Arial" pitchFamily="34" charset="-120"/>
               </a:rPr>
-              <a:t>工具试用到付费服务的转化路径尚未系统化追踪，缺少量化基线</a:t>
+              <a:t>工具后台无埋点：不清楚用户从「试用评估」到「预约专家解读」的转化比例</a:t>
             </a:r>
             <a:endParaRPr lang="en-US" sz="1150" dirty="0"/>
           </a:p>
@@ -3428,7 +3428,7 @@
                 <a:ea typeface="Arial" pitchFamily="34" charset="-122"/>
                 <a:cs typeface="Arial" pitchFamily="34" charset="-120"/>
               </a:rPr>
-              <a:t>内容触达与工具/咨询入口之间缺少串联，流量未充分转化为线索</a:t>
+              <a:t>月报/文章末尾未放置工具入口，阅读流量没有导流到一点通或咨询预约</a:t>
             </a:r>
             <a:endParaRPr lang="en-US" sz="1150" dirty="0"/>
           </a:p>
@@ -3537,7 +3537,7 @@
                 <a:ea typeface="Arial" pitchFamily="34" charset="-122"/>
                 <a:cs typeface="Arial" pitchFamily="34" charset="-120"/>
               </a:rPr>
-              <a:t>新客户、新市场拓展多为被动响应，缺少主动触达节奏</a:t>
+              <a:t>新客户拓展靠等来访——没有目标客户名单，未做过定向推送</a:t>
             </a:r>
             <a:endParaRPr lang="en-US" sz="1150" dirty="0"/>
           </a:p>
@@ -3646,7 +3646,7 @@
                 <a:ea typeface="Arial" pitchFamily="34" charset="-122"/>
                 <a:cs typeface="Arial" pitchFamily="34" charset="-120"/>
               </a:rPr>
-              <a:t>行业会议、渠道合作等品牌曝光机会把握较少</a:t>
+              <a:t>Q4 有汽车行业展会/论坛，但目前无参会计划或合规主题资料储备</a:t>
             </a:r>
             <a:endParaRPr lang="en-US" sz="1150" dirty="0"/>
           </a:p>
@@ -3996,7 +3996,7 @@
                 <a:ea typeface="Georgia" pitchFamily="34" charset="-122"/>
                 <a:cs typeface="Georgia" pitchFamily="34" charset="-120"/>
               </a:rPr>
-              <a:t>以一点通平台为核心抓手，提升汽车板块客户增长与线索转化能力，为 2027 年规模化获客打基础。</a:t>
+              <a:t>依托一点通工具与法规内容体系，打通「内容触达 → 工具试用 → 咨询转化」链路，Q4 建立可追踪的获客与转化基线。</a:t>
             </a:r>
             <a:endParaRPr lang="en-US" sz="1800" dirty="0"/>
           </a:p>
@@ -4070,7 +4070,7 @@
         <p:spPr>
           <a:xfrm>
             <a:off x="768096" y="4937760"/>
-            <a:ext cx="8588959" cy="329184"/>
+            <a:ext cx="8588959" cy="566928"/>
           </a:xfrm>
           <a:prstGeom prst="rect">
             <a:avLst/>
@@ -4097,7 +4097,7 @@
                 <a:ea typeface="Arial" pitchFamily="34" charset="-122"/>
                 <a:cs typeface="Arial" pitchFamily="34" charset="-120"/>
               </a:rPr>
-              <a:t>聚焦客户增长与线索转化作为 Q4 首要目标，兼顾内容影响力与业务拓展两条支撑线。</a:t>
+              <a:t>核心抓手：一点通合规评估工具（已上线）+ 月报/推广文章（已稳定产出），Q4 重点是把两者串起来。</a:t>
             </a:r>
             <a:endParaRPr lang="en-US" sz="1150" dirty="0"/>
           </a:p>
@@ -4111,7 +4111,7 @@
         </p:nvSpPr>
         <p:spPr>
           <a:xfrm>
-            <a:off x="566928" y="5422392"/>
+            <a:off x="566928" y="5660136"/>
             <a:ext cx="54864" cy="54864"/>
           </a:xfrm>
           <a:prstGeom prst="ellipse">
@@ -4131,8 +4131,8 @@
         </p:nvSpPr>
         <p:spPr>
           <a:xfrm>
-            <a:off x="768096" y="5321808"/>
-            <a:ext cx="8588959" cy="329184"/>
+            <a:off x="768096" y="5559552"/>
+            <a:ext cx="8588959" cy="566928"/>
           </a:xfrm>
           <a:prstGeom prst="rect">
             <a:avLst/>
@@ -4159,7 +4159,7 @@
                 <a:ea typeface="Arial" pitchFamily="34" charset="-122"/>
                 <a:cs typeface="Arial" pitchFamily="34" charset="-120"/>
               </a:rPr>
-              <a:t>三大方向协同推进：工具获客转化、内容影响力与线索导流、客户增长与业务拓展。</a:t>
+              <a:t>三件事：① 工具后台埋点，搞清楚转化漏斗数据；② 内容端统一加工具入口，让阅读量变成线索；③ 筛目标客户做定向推送，从被动等变主动找。</a:t>
             </a:r>
             <a:endParaRPr lang="en-US" sz="1150" dirty="0"/>
           </a:p>
@@ -4173,7 +4173,7 @@
         </p:nvSpPr>
         <p:spPr>
           <a:xfrm>
-            <a:off x="566928" y="5806440"/>
+            <a:off x="566928" y="6281928"/>
             <a:ext cx="54864" cy="54864"/>
           </a:xfrm>
           <a:prstGeom prst="ellipse">
@@ -4193,8 +4193,8 @@
         </p:nvSpPr>
         <p:spPr>
           <a:xfrm>
-            <a:off x="768096" y="5705856"/>
-            <a:ext cx="8588959" cy="329184"/>
+            <a:off x="768096" y="6181344"/>
+            <a:ext cx="8588959" cy="566928"/>
           </a:xfrm>
           <a:prstGeom prst="rect">
             <a:avLst/>
@@ -4221,7 +4221,7 @@
                 <a:ea typeface="Arial" pitchFamily="34" charset="-122"/>
                 <a:cs typeface="Arial" pitchFamily="34" charset="-120"/>
               </a:rPr>
-              <a:t>采用方向性目标表述，先建立可追踪的基线，再在后续季度迭代量化。</a:t>
+              <a:t>Q4 目标是「建基线、跑通路径」，不追求一次性冲量；数据验证后 2027 年再定量化指标。</a:t>
             </a:r>
             <a:endParaRPr lang="en-US" sz="1150" dirty="0"/>
           </a:p>
@@ -4563,11 +4563,11 @@
         <p:spPr>
           <a:xfrm>
             <a:off x="548640" y="3026664"/>
-            <a:ext cx="2753258" cy="585216"/>
+            <a:ext cx="2753258" cy="777240"/>
           </a:xfrm>
           <a:prstGeom prst="roundRect">
             <a:avLst>
-              <a:gd name="adj" fmla="val 7813"/>
+              <a:gd name="adj" fmla="val 5882"/>
             </a:avLst>
           </a:prstGeom>
           <a:solidFill>
@@ -4629,7 +4629,7 @@
         <p:spPr>
           <a:xfrm>
             <a:off x="640080" y="3246120"/>
-            <a:ext cx="2570378" cy="429768"/>
+            <a:ext cx="2570378" cy="621792"/>
           </a:xfrm>
           <a:prstGeom prst="rect">
             <a:avLst/>
@@ -4656,7 +4656,7 @@
                 <a:ea typeface="Arial" pitchFamily="34" charset="-122"/>
                 <a:cs typeface="Arial" pitchFamily="34" charset="-120"/>
               </a:rPr>
-              <a:t>建立试用→评估→转化的数据追踪基线，识别转化率提升空间</a:t>
+              <a:t>一点通后台加埋点：记录「访问→试用评估→预约专家→正式咨询」各步骤数据，形成转化漏斗基线</a:t>
             </a:r>
             <a:endParaRPr lang="en-US" sz="950" dirty="0"/>
           </a:p>
@@ -4670,7 +4670,7 @@
         </p:nvSpPr>
         <p:spPr>
           <a:xfrm>
-            <a:off x="548640" y="3721608"/>
+            <a:off x="548640" y="3913632"/>
             <a:ext cx="2753258" cy="585216"/>
           </a:xfrm>
           <a:prstGeom prst="roundRect">
@@ -4697,7 +4697,7 @@
         </p:nvSpPr>
         <p:spPr>
           <a:xfrm>
-            <a:off x="640080" y="3785616"/>
+            <a:off x="640080" y="3977640"/>
             <a:ext cx="457200" cy="182880"/>
           </a:xfrm>
           <a:prstGeom prst="rect">
@@ -4736,7 +4736,7 @@
         </p:nvSpPr>
         <p:spPr>
           <a:xfrm>
-            <a:off x="640080" y="3941064"/>
+            <a:off x="640080" y="4133088"/>
             <a:ext cx="2570378" cy="429768"/>
           </a:xfrm>
           <a:prstGeom prst="rect">
@@ -4764,7 +4764,7 @@
                 <a:ea typeface="Arial" pitchFamily="34" charset="-122"/>
                 <a:cs typeface="Arial" pitchFamily="34" charset="-120"/>
               </a:rPr>
-              <a:t>推动「预约专家解读」「法规订阅」等转化设计的使用率环比提升</a:t>
+              <a:t>优化「预约专家解读」的入口位置与引导文案，提升评估完成后的咨询预约率</a:t>
             </a:r>
             <a:endParaRPr lang="en-US" sz="950" dirty="0"/>
           </a:p>
@@ -4778,7 +4778,7 @@
         </p:nvSpPr>
         <p:spPr>
           <a:xfrm>
-            <a:off x="548640" y="4416552"/>
+            <a:off x="548640" y="4608576"/>
             <a:ext cx="2753258" cy="585216"/>
           </a:xfrm>
           <a:prstGeom prst="roundRect">
@@ -4805,7 +4805,7 @@
         </p:nvSpPr>
         <p:spPr>
           <a:xfrm>
-            <a:off x="640080" y="4480560"/>
+            <a:off x="640080" y="4672584"/>
             <a:ext cx="457200" cy="182880"/>
           </a:xfrm>
           <a:prstGeom prst="rect">
@@ -4844,7 +4844,7 @@
         </p:nvSpPr>
         <p:spPr>
           <a:xfrm>
-            <a:off x="640080" y="4636008"/>
+            <a:off x="640080" y="4828032"/>
             <a:ext cx="2570378" cy="429768"/>
           </a:xfrm>
           <a:prstGeom prst="rect">
@@ -4872,7 +4872,7 @@
                 <a:ea typeface="Arial" pitchFamily="34" charset="-122"/>
                 <a:cs typeface="Arial" pitchFamily="34" charset="-120"/>
               </a:rPr>
-              <a:t>新增至少一类专项评估模块，扩大工具覆盖场景</a:t>
+              <a:t>上线电池法规/碳足迹等新兴领域专项评估模块，覆盖客户新增出口合规需求</a:t>
             </a:r>
             <a:endParaRPr lang="en-US" sz="950" dirty="0"/>
           </a:p>
@@ -4977,7 +4977,7 @@
                 <a:ea typeface="Georgia" pitchFamily="34" charset="-122"/>
                 <a:cs typeface="Georgia" pitchFamily="34" charset="-120"/>
               </a:rPr>
-              <a:t>内容影响力与线索导流</a:t>
+              <a:t>内容导流与线索获取</a:t>
             </a:r>
             <a:endParaRPr lang="en-US" sz="1250" dirty="0"/>
           </a:p>
@@ -5108,7 +5108,7 @@
                 <a:ea typeface="Arial" pitchFamily="34" charset="-122"/>
                 <a:cs typeface="Arial" pitchFamily="34" charset="-120"/>
               </a:rPr>
-              <a:t>月报与推广文章保持稳定产出节奏，阅读与转发量环比提升</a:t>
+              <a:t>月报按月、推广文章按周持续产出，每篇文末固定放置一点通评估入口链接</a:t>
             </a:r>
             <a:endParaRPr lang="en-US" sz="950" dirty="0"/>
           </a:p>
@@ -5123,11 +5123,11 @@
         <p:spPr>
           <a:xfrm>
             <a:off x="3576218" y="3721608"/>
-            <a:ext cx="2753258" cy="585216"/>
+            <a:ext cx="2753258" cy="777240"/>
           </a:xfrm>
           <a:prstGeom prst="roundRect">
             <a:avLst>
-              <a:gd name="adj" fmla="val 7813"/>
+              <a:gd name="adj" fmla="val 5882"/>
             </a:avLst>
           </a:prstGeom>
           <a:solidFill>
@@ -5189,7 +5189,7 @@
         <p:spPr>
           <a:xfrm>
             <a:off x="3667658" y="3941064"/>
-            <a:ext cx="2570378" cy="429768"/>
+            <a:ext cx="2570378" cy="621792"/>
           </a:xfrm>
           <a:prstGeom prst="rect">
             <a:avLst/>
@@ -5216,7 +5216,7 @@
                 <a:ea typeface="Arial" pitchFamily="34" charset="-122"/>
                 <a:cs typeface="Arial" pitchFamily="34" charset="-120"/>
               </a:rPr>
-              <a:t>内容中嵌入工具/咨询入口，打通内容到线索的转化路径</a:t>
+              <a:t>针对客户高频咨询问题产出 3–5 篇深度法规解读专题，作为定向推送获客素材</a:t>
             </a:r>
             <a:endParaRPr lang="en-US" sz="950" dirty="0"/>
           </a:p>
@@ -5230,7 +5230,7 @@
         </p:nvSpPr>
         <p:spPr>
           <a:xfrm>
-            <a:off x="3576218" y="4416552"/>
+            <a:off x="3576218" y="4608576"/>
             <a:ext cx="2753258" cy="585216"/>
           </a:xfrm>
           <a:prstGeom prst="roundRect">
@@ -5257,7 +5257,7 @@
         </p:nvSpPr>
         <p:spPr>
           <a:xfrm>
-            <a:off x="3667658" y="4480560"/>
+            <a:off x="3667658" y="4672584"/>
             <a:ext cx="457200" cy="182880"/>
           </a:xfrm>
           <a:prstGeom prst="rect">
@@ -5296,7 +5296,7 @@
         </p:nvSpPr>
         <p:spPr>
           <a:xfrm>
-            <a:off x="3667658" y="4636008"/>
+            <a:off x="3667658" y="4828032"/>
             <a:ext cx="2570378" cy="429768"/>
           </a:xfrm>
           <a:prstGeom prst="rect">
@@ -5324,7 +5324,7 @@
                 <a:ea typeface="Arial" pitchFamily="34" charset="-122"/>
                 <a:cs typeface="Arial" pitchFamily="34" charset="-120"/>
               </a:rPr>
-              <a:t>试点一种新内容形式（如专题直播），验证导流效果</a:t>
+              <a:t>建立法规速递邮件机制，按客户关注市场定向推送法规动态与工具入口</a:t>
             </a:r>
             <a:endParaRPr lang="en-US" sz="950" dirty="0"/>
           </a:p>
@@ -5560,7 +5560,7 @@
                 <a:ea typeface="Arial" pitchFamily="34" charset="-122"/>
                 <a:cs typeface="Arial" pitchFamily="34" charset="-120"/>
               </a:rPr>
-              <a:t>现有核心客户深化合作，推进增量需求对接</a:t>
+              <a:t>汽研等核心客户：主动对接新增市场的法规数据需求，推进增量数据交付订单</a:t>
             </a:r>
             <a:endParaRPr lang="en-US" sz="950" dirty="0"/>
           </a:p>
@@ -5575,11 +5575,11 @@
         <p:spPr>
           <a:xfrm>
             <a:off x="6603797" y="3721608"/>
-            <a:ext cx="2753258" cy="585216"/>
+            <a:ext cx="2753258" cy="777240"/>
           </a:xfrm>
           <a:prstGeom prst="roundRect">
             <a:avLst>
-              <a:gd name="adj" fmla="val 7813"/>
+              <a:gd name="adj" fmla="val 5882"/>
             </a:avLst>
           </a:prstGeom>
           <a:solidFill>
@@ -5641,7 +5641,7 @@
         <p:spPr>
           <a:xfrm>
             <a:off x="6695237" y="3941064"/>
-            <a:ext cx="2570378" cy="429768"/>
+            <a:ext cx="2570378" cy="621792"/>
           </a:xfrm>
           <a:prstGeom prst="rect">
             <a:avLst/>
@@ -5668,7 +5668,7 @@
                 <a:ea typeface="Arial" pitchFamily="34" charset="-122"/>
                 <a:cs typeface="Arial" pitchFamily="34" charset="-120"/>
               </a:rPr>
-              <a:t>主动触达一批新客户/新市场，建立初步合作意向</a:t>
+              <a:t>从主机厂、Tier 1、出口贸易商中各筛选目标企业，定向推送月报与工具试用邀请</a:t>
             </a:r>
             <a:endParaRPr lang="en-US" sz="950" dirty="0"/>
           </a:p>
@@ -5682,12 +5682,12 @@
         </p:nvSpPr>
         <p:spPr>
           <a:xfrm>
-            <a:off x="6603797" y="4416552"/>
-            <a:ext cx="2753258" cy="585216"/>
+            <a:off x="6603797" y="4608576"/>
+            <a:ext cx="2753258" cy="777240"/>
           </a:xfrm>
           <a:prstGeom prst="roundRect">
             <a:avLst>
-              <a:gd name="adj" fmla="val 7813"/>
+              <a:gd name="adj" fmla="val 5882"/>
             </a:avLst>
           </a:prstGeom>
           <a:solidFill>
@@ -5709,7 +5709,7 @@
         </p:nvSpPr>
         <p:spPr>
           <a:xfrm>
-            <a:off x="6695237" y="4480560"/>
+            <a:off x="6695237" y="4672584"/>
             <a:ext cx="457200" cy="182880"/>
           </a:xfrm>
           <a:prstGeom prst="rect">
@@ -5748,8 +5748,8 @@
         </p:nvSpPr>
         <p:spPr>
           <a:xfrm>
-            <a:off x="6695237" y="4636008"/>
-            <a:ext cx="2570378" cy="429768"/>
+            <a:off x="6695237" y="4828032"/>
+            <a:ext cx="2570378" cy="621792"/>
           </a:xfrm>
           <a:prstGeom prst="rect">
             <a:avLst/>
@@ -5776,7 +5776,7 @@
                 <a:ea typeface="Arial" pitchFamily="34" charset="-122"/>
                 <a:cs typeface="Arial" pitchFamily="34" charset="-120"/>
               </a:rPr>
-              <a:t>把握至少一次行业会议或渠道合作机会，扩大品牌曝光</a:t>
+              <a:t>参加 Q4 汽车行业展会/论坛，备好法规合规主题资料，现场获取潜在客户联系方式</a:t>
             </a:r>
             <a:endParaRPr lang="en-US" sz="950" dirty="0"/>
           </a:p>
@@ -6051,11 +6051,11 @@
         <p:spPr>
           <a:xfrm>
             <a:off x="548640" y="2935224"/>
-            <a:ext cx="2753258" cy="374904"/>
+            <a:ext cx="2753258" cy="566928"/>
           </a:xfrm>
           <a:prstGeom prst="roundRect">
             <a:avLst>
-              <a:gd name="adj" fmla="val 12195"/>
+              <a:gd name="adj" fmla="val 8065"/>
             </a:avLst>
           </a:prstGeom>
           <a:solidFill>
@@ -6078,7 +6078,7 @@
         <p:spPr>
           <a:xfrm>
             <a:off x="566928" y="2971800"/>
-            <a:ext cx="27432" cy="301752"/>
+            <a:ext cx="27432" cy="493776"/>
           </a:xfrm>
           <a:prstGeom prst="rect">
             <a:avLst/>
@@ -6098,7 +6098,7 @@
         <p:spPr>
           <a:xfrm>
             <a:off x="713232" y="3008376"/>
-            <a:ext cx="2478938" cy="237744"/>
+            <a:ext cx="2478938" cy="429768"/>
           </a:xfrm>
           <a:prstGeom prst="rect">
             <a:avLst/>
@@ -6125,7 +6125,7 @@
                 <a:ea typeface="Arial" pitchFamily="34" charset="-122"/>
                 <a:cs typeface="Arial" pitchFamily="34" charset="-120"/>
               </a:rPr>
-              <a:t>搭建试用→转化数据追踪基线</a:t>
+              <a:t>一点通后台埋点上线，开始记录各步骤转化数据</a:t>
             </a:r>
             <a:endParaRPr lang="en-US" sz="1000" dirty="0"/>
           </a:p>
@@ -6139,12 +6139,12 @@
         </p:nvSpPr>
         <p:spPr>
           <a:xfrm>
-            <a:off x="548640" y="3419856"/>
-            <a:ext cx="2753258" cy="374904"/>
+            <a:off x="548640" y="3611880"/>
+            <a:ext cx="2753258" cy="566928"/>
           </a:xfrm>
           <a:prstGeom prst="roundRect">
             <a:avLst>
-              <a:gd name="adj" fmla="val 12195"/>
+              <a:gd name="adj" fmla="val 8065"/>
             </a:avLst>
           </a:prstGeom>
           <a:solidFill>
@@ -6166,8 +6166,8 @@
         </p:nvSpPr>
         <p:spPr>
           <a:xfrm>
-            <a:off x="566928" y="3456432"/>
-            <a:ext cx="27432" cy="301752"/>
+            <a:off x="566928" y="3648456"/>
+            <a:ext cx="27432" cy="493776"/>
           </a:xfrm>
           <a:prstGeom prst="rect">
             <a:avLst/>
@@ -6186,8 +6186,8 @@
         </p:nvSpPr>
         <p:spPr>
           <a:xfrm>
-            <a:off x="713232" y="3493008"/>
-            <a:ext cx="2478938" cy="237744"/>
+            <a:off x="713232" y="3685032"/>
+            <a:ext cx="2478938" cy="429768"/>
           </a:xfrm>
           <a:prstGeom prst="rect">
             <a:avLst/>
@@ -6214,7 +6214,7 @@
                 <a:ea typeface="Arial" pitchFamily="34" charset="-122"/>
                 <a:cs typeface="Arial" pitchFamily="34" charset="-120"/>
               </a:rPr>
-              <a:t>内容嵌入工具入口试点上线</a:t>
+              <a:t>月报/文章统一嵌入一点通评估入口链接</a:t>
             </a:r>
             <a:endParaRPr lang="en-US" sz="1000" dirty="0"/>
           </a:p>
@@ -6228,12 +6228,12 @@
         </p:nvSpPr>
         <p:spPr>
           <a:xfrm>
-            <a:off x="548640" y="3904488"/>
-            <a:ext cx="2753258" cy="374904"/>
+            <a:off x="548640" y="4288536"/>
+            <a:ext cx="2753258" cy="566928"/>
           </a:xfrm>
           <a:prstGeom prst="roundRect">
             <a:avLst>
-              <a:gd name="adj" fmla="val 12195"/>
+              <a:gd name="adj" fmla="val 8065"/>
             </a:avLst>
           </a:prstGeom>
           <a:solidFill>
@@ -6255,8 +6255,8 @@
         </p:nvSpPr>
         <p:spPr>
           <a:xfrm>
-            <a:off x="566928" y="3941064"/>
-            <a:ext cx="27432" cy="301752"/>
+            <a:off x="566928" y="4325112"/>
+            <a:ext cx="27432" cy="493776"/>
           </a:xfrm>
           <a:prstGeom prst="rect">
             <a:avLst/>
@@ -6275,8 +6275,8 @@
         </p:nvSpPr>
         <p:spPr>
           <a:xfrm>
-            <a:off x="713232" y="3977640"/>
-            <a:ext cx="2478938" cy="237744"/>
+            <a:off x="713232" y="4361688"/>
+            <a:ext cx="2478938" cy="429768"/>
           </a:xfrm>
           <a:prstGeom prst="rect">
             <a:avLst/>
@@ -6303,7 +6303,7 @@
                 <a:ea typeface="Arial" pitchFamily="34" charset="-122"/>
                 <a:cs typeface="Arial" pitchFamily="34" charset="-120"/>
               </a:rPr>
-              <a:t>新客户/新市场名单梳理与首轮触达</a:t>
+              <a:t>梳理目标客户名单，首轮定向推送法规月报</a:t>
             </a:r>
             <a:endParaRPr lang="en-US" sz="1000" dirty="0"/>
           </a:p>
@@ -6379,11 +6379,11 @@
         <p:spPr>
           <a:xfrm>
             <a:off x="3576218" y="2935224"/>
-            <a:ext cx="2753258" cy="374904"/>
+            <a:ext cx="2753258" cy="566928"/>
           </a:xfrm>
           <a:prstGeom prst="roundRect">
             <a:avLst>
-              <a:gd name="adj" fmla="val 12195"/>
+              <a:gd name="adj" fmla="val 8065"/>
             </a:avLst>
           </a:prstGeom>
           <a:solidFill>
@@ -6406,7 +6406,7 @@
         <p:spPr>
           <a:xfrm>
             <a:off x="3594506" y="2971800"/>
-            <a:ext cx="27432" cy="301752"/>
+            <a:ext cx="27432" cy="493776"/>
           </a:xfrm>
           <a:prstGeom prst="rect">
             <a:avLst/>
@@ -6426,7 +6426,7 @@
         <p:spPr>
           <a:xfrm>
             <a:off x="3740810" y="3008376"/>
-            <a:ext cx="2478938" cy="237744"/>
+            <a:ext cx="2478938" cy="429768"/>
           </a:xfrm>
           <a:prstGeom prst="rect">
             <a:avLst/>
@@ -6453,7 +6453,7 @@
                 <a:ea typeface="Arial" pitchFamily="34" charset="-122"/>
                 <a:cs typeface="Arial" pitchFamily="34" charset="-120"/>
               </a:rPr>
-              <a:t>转化设计迭代优化（订阅/专家解读）</a:t>
+              <a:t>优化「预约专家解读」引导流程与入口文案</a:t>
             </a:r>
             <a:endParaRPr lang="en-US" sz="1000" dirty="0"/>
           </a:p>
@@ -6467,12 +6467,12 @@
         </p:nvSpPr>
         <p:spPr>
           <a:xfrm>
-            <a:off x="3576218" y="3419856"/>
-            <a:ext cx="2753258" cy="374904"/>
+            <a:off x="3576218" y="3611880"/>
+            <a:ext cx="2753258" cy="566928"/>
           </a:xfrm>
           <a:prstGeom prst="roundRect">
             <a:avLst>
-              <a:gd name="adj" fmla="val 12195"/>
+              <a:gd name="adj" fmla="val 8065"/>
             </a:avLst>
           </a:prstGeom>
           <a:solidFill>
@@ -6494,8 +6494,8 @@
         </p:nvSpPr>
         <p:spPr>
           <a:xfrm>
-            <a:off x="3594506" y="3456432"/>
-            <a:ext cx="27432" cy="301752"/>
+            <a:off x="3594506" y="3648456"/>
+            <a:ext cx="27432" cy="493776"/>
           </a:xfrm>
           <a:prstGeom prst="rect">
             <a:avLst/>
@@ -6514,8 +6514,8 @@
         </p:nvSpPr>
         <p:spPr>
           <a:xfrm>
-            <a:off x="3740810" y="3493008"/>
-            <a:ext cx="2478938" cy="237744"/>
+            <a:off x="3740810" y="3685032"/>
+            <a:ext cx="2478938" cy="429768"/>
           </a:xfrm>
           <a:prstGeom prst="rect">
             <a:avLst/>
@@ -6542,7 +6542,7 @@
                 <a:ea typeface="Arial" pitchFamily="34" charset="-122"/>
                 <a:cs typeface="Arial" pitchFamily="34" charset="-120"/>
               </a:rPr>
-              <a:t>新内容形式（专题直播等）试点</a:t>
+              <a:t>产出 2–3 篇深度法规专题，定向推送至目标客户</a:t>
             </a:r>
             <a:endParaRPr lang="en-US" sz="1000" dirty="0"/>
           </a:p>
@@ -6556,12 +6556,12 @@
         </p:nvSpPr>
         <p:spPr>
           <a:xfrm>
-            <a:off x="3576218" y="3904488"/>
-            <a:ext cx="2753258" cy="374904"/>
+            <a:off x="3576218" y="4288536"/>
+            <a:ext cx="2753258" cy="566928"/>
           </a:xfrm>
           <a:prstGeom prst="roundRect">
             <a:avLst>
-              <a:gd name="adj" fmla="val 12195"/>
+              <a:gd name="adj" fmla="val 8065"/>
             </a:avLst>
           </a:prstGeom>
           <a:solidFill>
@@ -6583,8 +6583,8 @@
         </p:nvSpPr>
         <p:spPr>
           <a:xfrm>
-            <a:off x="3594506" y="3941064"/>
-            <a:ext cx="27432" cy="301752"/>
+            <a:off x="3594506" y="4325112"/>
+            <a:ext cx="27432" cy="493776"/>
           </a:xfrm>
           <a:prstGeom prst="rect">
             <a:avLst/>
@@ -6603,8 +6603,8 @@
         </p:nvSpPr>
         <p:spPr>
           <a:xfrm>
-            <a:off x="3740810" y="3977640"/>
-            <a:ext cx="2478938" cy="237744"/>
+            <a:off x="3740810" y="4361688"/>
+            <a:ext cx="2478938" cy="429768"/>
           </a:xfrm>
           <a:prstGeom prst="rect">
             <a:avLst/>
@@ -6631,7 +6631,7 @@
                 <a:ea typeface="Arial" pitchFamily="34" charset="-122"/>
                 <a:cs typeface="Arial" pitchFamily="34" charset="-120"/>
               </a:rPr>
-              <a:t>核心客户深化合作推进</a:t>
+              <a:t>汽研等核心客户增量需求对接与交付跟进</a:t>
             </a:r>
             <a:endParaRPr lang="en-US" sz="1000" dirty="0"/>
           </a:p>
@@ -6707,11 +6707,11 @@
         <p:spPr>
           <a:xfrm>
             <a:off x="6603797" y="2935224"/>
-            <a:ext cx="2753258" cy="374904"/>
+            <a:ext cx="2753258" cy="566928"/>
           </a:xfrm>
           <a:prstGeom prst="roundRect">
             <a:avLst>
-              <a:gd name="adj" fmla="val 12195"/>
+              <a:gd name="adj" fmla="val 8065"/>
             </a:avLst>
           </a:prstGeom>
           <a:solidFill>
@@ -6734,7 +6734,7 @@
         <p:spPr>
           <a:xfrm>
             <a:off x="6622085" y="2971800"/>
-            <a:ext cx="27432" cy="301752"/>
+            <a:ext cx="27432" cy="493776"/>
           </a:xfrm>
           <a:prstGeom prst="rect">
             <a:avLst/>
@@ -6754,7 +6754,7 @@
         <p:spPr>
           <a:xfrm>
             <a:off x="6768389" y="3008376"/>
-            <a:ext cx="2478938" cy="237744"/>
+            <a:ext cx="2478938" cy="429768"/>
           </a:xfrm>
           <a:prstGeom prst="rect">
             <a:avLst/>
@@ -6781,7 +6781,7 @@
                 <a:ea typeface="Arial" pitchFamily="34" charset="-122"/>
                 <a:cs typeface="Arial" pitchFamily="34" charset="-120"/>
               </a:rPr>
-              <a:t>Q4 成果复盘与基线数据验证</a:t>
+              <a:t>汇总 Q4 转化漏斗数据，验证基线并输出复盘报告</a:t>
             </a:r>
             <a:endParaRPr lang="en-US" sz="1000" dirty="0"/>
           </a:p>
@@ -6795,12 +6795,12 @@
         </p:nvSpPr>
         <p:spPr>
           <a:xfrm>
-            <a:off x="6603797" y="3419856"/>
-            <a:ext cx="2753258" cy="374904"/>
+            <a:off x="6603797" y="3611880"/>
+            <a:ext cx="2753258" cy="566928"/>
           </a:xfrm>
           <a:prstGeom prst="roundRect">
             <a:avLst>
-              <a:gd name="adj" fmla="val 12195"/>
+              <a:gd name="adj" fmla="val 8065"/>
             </a:avLst>
           </a:prstGeom>
           <a:solidFill>
@@ -6822,8 +6822,8 @@
         </p:nvSpPr>
         <p:spPr>
           <a:xfrm>
-            <a:off x="6622085" y="3456432"/>
-            <a:ext cx="27432" cy="301752"/>
+            <a:off x="6622085" y="3648456"/>
+            <a:ext cx="27432" cy="493776"/>
           </a:xfrm>
           <a:prstGeom prst="rect">
             <a:avLst/>
@@ -6842,8 +6842,8 @@
         </p:nvSpPr>
         <p:spPr>
           <a:xfrm>
-            <a:off x="6768389" y="3493008"/>
-            <a:ext cx="2478938" cy="237744"/>
+            <a:off x="6768389" y="3685032"/>
+            <a:ext cx="2478938" cy="429768"/>
           </a:xfrm>
           <a:prstGeom prst="rect">
             <a:avLst/>
@@ -6870,7 +6870,7 @@
                 <a:ea typeface="Arial" pitchFamily="34" charset="-122"/>
                 <a:cs typeface="Arial" pitchFamily="34" charset="-120"/>
               </a:rPr>
-              <a:t>新客户合作意向落地跟进</a:t>
+              <a:t>目标客户合作意向跟进，推动试用/签约落地</a:t>
             </a:r>
             <a:endParaRPr lang="en-US" sz="1000" dirty="0"/>
           </a:p>
@@ -6884,12 +6884,12 @@
         </p:nvSpPr>
         <p:spPr>
           <a:xfrm>
-            <a:off x="6603797" y="3904488"/>
-            <a:ext cx="2753258" cy="374904"/>
+            <a:off x="6603797" y="4288536"/>
+            <a:ext cx="2753258" cy="566928"/>
           </a:xfrm>
           <a:prstGeom prst="roundRect">
             <a:avLst>
-              <a:gd name="adj" fmla="val 12195"/>
+              <a:gd name="adj" fmla="val 8065"/>
             </a:avLst>
           </a:prstGeom>
           <a:solidFill>
@@ -6911,8 +6911,8 @@
         </p:nvSpPr>
         <p:spPr>
           <a:xfrm>
-            <a:off x="6622085" y="3941064"/>
-            <a:ext cx="27432" cy="301752"/>
+            <a:off x="6622085" y="4325112"/>
+            <a:ext cx="27432" cy="493776"/>
           </a:xfrm>
           <a:prstGeom prst="rect">
             <a:avLst/>
@@ -6931,8 +6931,8 @@
         </p:nvSpPr>
         <p:spPr>
           <a:xfrm>
-            <a:off x="6768389" y="3977640"/>
-            <a:ext cx="2478938" cy="237744"/>
+            <a:off x="6768389" y="4361688"/>
+            <a:ext cx="2478938" cy="429768"/>
           </a:xfrm>
           <a:prstGeom prst="rect">
             <a:avLst/>
@@ -6959,7 +6959,7 @@
                 <a:ea typeface="Arial" pitchFamily="34" charset="-122"/>
                 <a:cs typeface="Arial" pitchFamily="34" charset="-120"/>
               </a:rPr>
-              <a:t>2027 年度计划启动筹备</a:t>
+              <a:t>基于 Q4 数据编制 2027 年度获客计划</a:t>
             </a:r>
             <a:endParaRPr lang="en-US" sz="1000" dirty="0"/>
           </a:p>
@@ -7356,7 +7356,7 @@
                 <a:ea typeface="Arial" pitchFamily="34" charset="-122"/>
                 <a:cs typeface="Arial" pitchFamily="34" charset="-120"/>
               </a:rPr>
-              <a:t>内容团队：支持新内容形式（专题直播/短视频）的策划与制作</a:t>
+              <a:t>内容团队：协助深度法规专题文章的选题策划与排版发布</a:t>
             </a:r>
             <a:endParaRPr lang="en-US" sz="1150" dirty="0"/>
           </a:p>
@@ -7465,7 +7465,7 @@
                 <a:ea typeface="Arial" pitchFamily="34" charset="-122"/>
                 <a:cs typeface="Arial" pitchFamily="34" charset="-120"/>
               </a:rPr>
-              <a:t>市场团队：协助新客户触达渠道梳理与行业会议资源对接</a:t>
+              <a:t>市场团队：提供行业展会/论坛参会资源，协助目标客户名单的渠道梳理</a:t>
             </a:r>
             <a:endParaRPr lang="en-US" sz="1150" dirty="0"/>
           </a:p>
@@ -7574,7 +7574,7 @@
                 <a:ea typeface="Arial" pitchFamily="34" charset="-122"/>
                 <a:cs typeface="Arial" pitchFamily="34" charset="-120"/>
               </a:rPr>
-              <a:t>IT/工具团队：支持试用→转化数据追踪基线的技术搭建</a:t>
+              <a:t>IT/工具团队：一点通后台埋点开发与转化漏斗数据看板搭建</a:t>
             </a:r>
             <a:endParaRPr lang="en-US" sz="1150" dirty="0"/>
           </a:p>
@@ -7772,7 +7772,7 @@
                 <a:ea typeface="Arial" pitchFamily="34" charset="-122"/>
                 <a:cs typeface="Arial" pitchFamily="34" charset="-120"/>
               </a:rPr>
-              <a:t>转化路径数据追踪尚处起步，Q4 以建立基线为主，不强求量化达成</a:t>
+              <a:t>埋点与数据看板开发需 IT 排期，10 月初与 IT 对齐需求，确保月中上线</a:t>
             </a:r>
             <a:endParaRPr lang="en-US" sz="1150" dirty="0"/>
           </a:p>
@@ -7881,7 +7881,7 @@
                 <a:ea typeface="Arial" pitchFamily="34" charset="-122"/>
                 <a:cs typeface="Arial" pitchFamily="34" charset="-120"/>
               </a:rPr>
-              <a:t>跨团队协作节奏需提前对齐，避免因资源排期影响执行进度</a:t>
+              <a:t>目标客户名单筛选依赖行业信息，与市场团队共建，避免闭门造车</a:t>
             </a:r>
             <a:endParaRPr lang="en-US" sz="1150" dirty="0"/>
           </a:p>
@@ -7990,7 +7990,7 @@
                 <a:ea typeface="Arial" pitchFamily="34" charset="-122"/>
                 <a:cs typeface="Arial" pitchFamily="34" charset="-120"/>
               </a:rPr>
-              <a:t>新客户拓展周期较长，Q4 以建立意向为目标，落地签约滚动至后续季度</a:t>
+              <a:t>新客户拓展周期长，Q4 以建立联系和试用意向为主，签约目标滚动至 Q1</a:t>
             </a:r>
             <a:endParaRPr lang="en-US" sz="1150" dirty="0"/>
           </a:p>
@@ -8322,7 +8322,7 @@
                 <a:ea typeface="Arial" pitchFamily="34" charset="-122"/>
                 <a:cs typeface="Arial" pitchFamily="34" charset="-120"/>
               </a:rPr>
-              <a:t>每月向上级同步关键结果（KR）进展</a:t>
+              <a:t>每月底向上级同步 KR 进展：转化漏斗数据 + 客户触达进度 + 内容产出数</a:t>
             </a:r>
             <a:endParaRPr lang="en-US" sz="1150" dirty="0"/>
           </a:p>
@@ -8432,7 +8432,7 @@
                 <a:ea typeface="Arial" pitchFamily="34" charset="-122"/>
                 <a:cs typeface="Arial" pitchFamily="34" charset="-120"/>
               </a:rPr>
-              <a:t>Q4 末产出完整复盘报告，衔接 2027 年度规划</a:t>
+              <a:t>12 月底产出 Q4 复盘报告：含转化基线数据、客户触达结果，衔接 2027 年度计划</a:t>
             </a:r>
             <a:endParaRPr lang="en-US" sz="1150" dirty="0"/>
           </a:p>
@@ -8542,7 +8542,7 @@
                 <a:ea typeface="Arial" pitchFamily="34" charset="-122"/>
                 <a:cs typeface="Arial" pitchFamily="34" charset="-120"/>
               </a:rPr>
-              <a:t>沉淀可复用的转化追踪与内容导流机制，作为长期能力建设成果</a:t>
+              <a:t>交付物：转化漏斗数据看板 + 法规速递邮件模板 + 目标客户名单与跟进记录</a:t>
             </a:r>
             <a:endParaRPr lang="en-US" sz="1150" dirty="0"/>
           </a:p>
@@ -8652,7 +8652,7 @@
                 <a:ea typeface="Arial" pitchFamily="34" charset="-122"/>
                 <a:cs typeface="Arial" pitchFamily="34" charset="-120"/>
               </a:rPr>
-              <a:t>形成新客户/新市场拓展的首批合作意向清单</a:t>
+              <a:t>形成首批目标客户合作意向清单（主机厂/Tier 1/贸易商各若干家）</a:t>
             </a:r>
             <a:endParaRPr lang="en-US" sz="1150" dirty="0"/>
           </a:p>

</xml_diff>

<commit_message>
Adjust Q4 roadmap: tool launch moved to November
- October: IT requirements alignment + start development (not go-live)
- November: backend instrumentation goes live
- December: optimize based on collected data
- Updated risk item timeline accordingly

Co-Authored-By: Claude Opus 4.6 <noreply@anthropic.com>
Claude-Session: https://claude.ai/code/session_015nf3knxVoVVLYAWgtjzRg9
</commit_message>
<xml_diff>
--- a/汽车板块Q4推广计划.pptx
+++ b/汽车板块Q4推广计划.pptx
@@ -6125,7 +6125,7 @@
                 <a:ea typeface="Arial" pitchFamily="34" charset="-122"/>
                 <a:cs typeface="Arial" pitchFamily="34" charset="-120"/>
               </a:rPr>
-              <a:t>一点通后台埋点上线，开始记录各步骤转化数据</a:t>
+              <a:t>与 IT 对齐埋点需求，启动一点通后台开发</a:t>
             </a:r>
             <a:endParaRPr lang="en-US" sz="1000" dirty="0"/>
           </a:p>
@@ -6453,7 +6453,7 @@
                 <a:ea typeface="Arial" pitchFamily="34" charset="-122"/>
                 <a:cs typeface="Arial" pitchFamily="34" charset="-120"/>
               </a:rPr>
-              <a:t>优化「预约专家解读」引导流程与入口文案</a:t>
+              <a:t>一点通后台埋点上线，开始记录转化漏斗数据</a:t>
             </a:r>
             <a:endParaRPr lang="en-US" sz="1000" dirty="0"/>
           </a:p>
@@ -6781,7 +6781,7 @@
                 <a:ea typeface="Arial" pitchFamily="34" charset="-122"/>
                 <a:cs typeface="Arial" pitchFamily="34" charset="-120"/>
               </a:rPr>
-              <a:t>汇总 Q4 转化漏斗数据，验证基线并输出复盘报告</a:t>
+              <a:t>基于埋点数据优化「预约专家解读」引导流程</a:t>
             </a:r>
             <a:endParaRPr lang="en-US" sz="1000" dirty="0"/>
           </a:p>
@@ -6959,7 +6959,7 @@
                 <a:ea typeface="Arial" pitchFamily="34" charset="-122"/>
                 <a:cs typeface="Arial" pitchFamily="34" charset="-120"/>
               </a:rPr>
-              <a:t>基于 Q4 数据编制 2027 年度获客计划</a:t>
+              <a:t>汇总 Q4 转化漏斗数据，输出复盘与 2027 计划</a:t>
             </a:r>
             <a:endParaRPr lang="en-US" sz="1000" dirty="0"/>
           </a:p>
@@ -7772,7 +7772,7 @@
                 <a:ea typeface="Arial" pitchFamily="34" charset="-122"/>
                 <a:cs typeface="Arial" pitchFamily="34" charset="-120"/>
               </a:rPr>
-              <a:t>埋点与数据看板开发需 IT 排期，10 月初与 IT 对齐需求，确保月中上线</a:t>
+              <a:t>埋点开发需 IT 排期，10 月对齐需求并启动开发，目标 11 月上线</a:t>
             </a:r>
             <a:endParaRPr lang="en-US" sz="1150" dirty="0"/>
           </a:p>

</xml_diff>